<commit_message>
Slides: hook questions on covers, copy within 10 words (sd-05-001..005)
Co-Authored-By: Claude Opus 5.5 <noreply@anthropic.com>
Claude-Session: https://claude.ai/code/session_01C9pH8NnezrynRr5dznPeP3
</commit_message>
<xml_diff>
--- a/system-design-101/vi/lessons/sd-05-001/slides/sd-05-001.pptx
+++ b/system-design-101/vi/lessons/sd-05-001/slides/sd-05-001.pptx
@@ -1925,7 +1925,7 @@
               <a:buNone/>
             </a:pPr>
             <a:r>
-              <a:rPr lang="en-US" sz="3000" dirty="0" spc="-2" kern="0">
+              <a:rPr lang="en-US" sz="3000" dirty="0" spc="-43" kern="0">
                 <a:solidFill>
                   <a:srgbClr val="E4E1D8"/>
                 </a:solidFill>
@@ -1933,10 +1933,10 @@
                 <a:ea typeface="Be Vietnam Pro" pitchFamily="34" charset="-122"/>
                 <a:cs typeface="Be Vietnam Pro" pitchFamily="34" charset="-120"/>
               </a:rPr>
-              <a:t>JOIN</a:t>
-            </a:r>
-            <a:r>
-              <a:rPr lang="en-US" sz="3000" dirty="0" spc="3" kern="0">
+              <a:t>Lọc</a:t>
+            </a:r>
+            <a:r>
+              <a:rPr lang="en-US" sz="3000" dirty="0" spc="-20" kern="0">
                 <a:solidFill>
                   <a:srgbClr val="E4E1D8"/>
                 </a:solidFill>
@@ -1944,10 +1944,10 @@
                 <a:ea typeface="Be Vietnam Pro" pitchFamily="34" charset="-122"/>
                 <a:cs typeface="Be Vietnam Pro" pitchFamily="34" charset="-120"/>
               </a:rPr>
-              <a:t> ghép</a:t>
-            </a:r>
-            <a:r>
-              <a:rPr lang="en-US" sz="3000" dirty="0" spc="2" kern="0">
+              <a:t> trong</a:t>
+            </a:r>
+            <a:r>
+              <a:rPr lang="en-US" sz="3000" dirty="0" spc="0" kern="0">
                 <a:solidFill>
                   <a:srgbClr val="E4E1D8"/>
                 </a:solidFill>
@@ -1955,7 +1955,40 @@
                 <a:ea typeface="Be Vietnam Pro" pitchFamily="34" charset="-122"/>
                 <a:cs typeface="Be Vietnam Pro" pitchFamily="34" charset="-120"/>
               </a:rPr>
-              <a:t> dòng</a:t>
+              <a:t> ON</a:t>
+            </a:r>
+            <a:r>
+              <a:rPr lang="en-US" sz="3000" dirty="0" spc="-11" kern="0">
+                <a:solidFill>
+                  <a:srgbClr val="E4E1D8"/>
+                </a:solidFill>
+                <a:latin typeface="Be Vietnam Pro" pitchFamily="34" charset="0"/>
+                <a:ea typeface="Be Vietnam Pro" pitchFamily="34" charset="-122"/>
+                <a:cs typeface="Be Vietnam Pro" pitchFamily="34" charset="-120"/>
+              </a:rPr>
+              <a:t> hay</a:t>
+            </a:r>
+            <a:r>
+              <a:rPr lang="en-US" sz="3000" dirty="0" spc="0" kern="0">
+                <a:solidFill>
+                  <a:srgbClr val="E4E1D8"/>
+                </a:solidFill>
+                <a:latin typeface="Be Vietnam Pro" pitchFamily="34" charset="0"/>
+                <a:ea typeface="Be Vietnam Pro" pitchFamily="34" charset="-122"/>
+                <a:cs typeface="Be Vietnam Pro" pitchFamily="34" charset="-120"/>
+              </a:rPr>
+              <a:t> WHERE:</a:t>
+            </a:r>
+            <a:r>
+              <a:rPr lang="en-US" sz="3000" dirty="0" spc="-40" kern="0">
+                <a:solidFill>
+                  <a:srgbClr val="E4E1D8"/>
+                </a:solidFill>
+                <a:latin typeface="Be Vietnam Pro" pitchFamily="34" charset="0"/>
+                <a:ea typeface="Be Vietnam Pro" pitchFamily="34" charset="-122"/>
+                <a:cs typeface="Be Vietnam Pro" pitchFamily="34" charset="-120"/>
+              </a:rPr>
+              <a:t> kết</a:t>
             </a:r>
             <a:r>
               <a:rPr lang="en-US" sz="3000" dirty="0" spc="1" kern="0">
@@ -1966,10 +1999,10 @@
                 <a:ea typeface="Be Vietnam Pro" pitchFamily="34" charset="-122"/>
                 <a:cs typeface="Be Vietnam Pro" pitchFamily="34" charset="-120"/>
               </a:rPr>
-              <a:t> của</a:t>
-            </a:r>
-            <a:r>
-              <a:rPr lang="en-US" sz="3000" dirty="0" spc="2" kern="0">
+              <a:t> quả</a:t>
+            </a:r>
+            <a:r>
+              <a:rPr lang="en-US" sz="3000" dirty="0" spc="0" kern="0">
                 <a:solidFill>
                   <a:srgbClr val="E4E1D8"/>
                 </a:solidFill>
@@ -1977,10 +2010,10 @@
                 <a:ea typeface="Be Vietnam Pro" pitchFamily="34" charset="-122"/>
                 <a:cs typeface="Be Vietnam Pro" pitchFamily="34" charset="-120"/>
               </a:rPr>
-              <a:t> hai</a:t>
-            </a:r>
-            <a:r>
-              <a:rPr lang="en-US" sz="3000" dirty="0" spc="-2" kern="0">
+              <a:t> khác</a:t>
+            </a:r>
+            <a:r>
+              <a:rPr lang="en-US" sz="3000" dirty="0" spc="1" kern="0">
                 <a:solidFill>
                   <a:srgbClr val="E4E1D8"/>
                 </a:solidFill>
@@ -1988,40 +2021,7 @@
                 <a:ea typeface="Be Vietnam Pro" pitchFamily="34" charset="-122"/>
                 <a:cs typeface="Be Vietnam Pro" pitchFamily="34" charset="-120"/>
               </a:rPr>
-              <a:t> bảng</a:t>
-            </a:r>
-            <a:r>
-              <a:rPr lang="en-US" sz="3000" dirty="0" spc="-4" kern="0">
-                <a:solidFill>
-                  <a:srgbClr val="E4E1D8"/>
-                </a:solidFill>
-                <a:latin typeface="Be Vietnam Pro" pitchFamily="34" charset="0"/>
-                <a:ea typeface="Be Vietnam Pro" pitchFamily="34" charset="-122"/>
-                <a:cs typeface="Be Vietnam Pro" pitchFamily="34" charset="-120"/>
-              </a:rPr>
-              <a:t> theo</a:t>
-            </a:r>
-            <a:r>
-              <a:rPr lang="en-US" sz="3000" dirty="0" spc="25" kern="0">
-                <a:solidFill>
-                  <a:srgbClr val="E4E1D8"/>
-                </a:solidFill>
-                <a:latin typeface="Be Vietnam Pro" pitchFamily="34" charset="0"/>
-                <a:ea typeface="Be Vietnam Pro" pitchFamily="34" charset="-122"/>
-                <a:cs typeface="Be Vietnam Pro" pitchFamily="34" charset="-120"/>
-              </a:rPr>
-              <a:t> điều</a:t>
-            </a:r>
-            <a:r>
-              <a:rPr lang="en-US" sz="3000" dirty="0" spc="0" kern="0">
-                <a:solidFill>
-                  <a:srgbClr val="E4E1D8"/>
-                </a:solidFill>
-                <a:latin typeface="Be Vietnam Pro" pitchFamily="34" charset="0"/>
-                <a:ea typeface="Be Vietnam Pro" pitchFamily="34" charset="-122"/>
-                <a:cs typeface="Be Vietnam Pro" pitchFamily="34" charset="-120"/>
-              </a:rPr>
-              <a:t> kiện.</a:t>
+              <a:t> gì?</a:t>
             </a:r>
             <a:endParaRPr lang="en-US" sz="3000" dirty="0"/>
           </a:p>
@@ -3522,7 +3522,7 @@
               <a:t> ngữ</a:t>
             </a:r>
             <a:r>
-              <a:rPr lang="en-US" sz="2400" dirty="0" spc="1" kern="0">
+              <a:rPr lang="en-US" sz="2400" dirty="0" spc="0" kern="0">
                 <a:solidFill>
                   <a:srgbClr val="E4E1D8"/>
                 </a:solidFill>
@@ -3530,10 +3530,10 @@
                 <a:ea typeface="Be Vietnam Pro" pitchFamily="34" charset="-122"/>
                 <a:cs typeface="Be Vietnam Pro" pitchFamily="34" charset="-120"/>
               </a:rPr>
-              <a:t> truy</a:t>
-            </a:r>
-            <a:r>
-              <a:rPr lang="en-US" sz="2400" dirty="0" spc="-12" kern="0">
+              <a:t> hỏi</a:t>
+            </a:r>
+            <a:r>
+              <a:rPr lang="en-US" sz="2400" dirty="0" spc="-15" kern="0">
                 <a:solidFill>
                   <a:srgbClr val="E4E1D8"/>
                 </a:solidFill>
@@ -3541,7 +3541,40 @@
                 <a:ea typeface="Be Vietnam Pro" pitchFamily="34" charset="-122"/>
                 <a:cs typeface="Be Vietnam Pro" pitchFamily="34" charset="-120"/>
               </a:rPr>
-              <a:t> vấn</a:t>
+              <a:t> và</a:t>
+            </a:r>
+            <a:r>
+              <a:rPr lang="en-US" sz="2400" dirty="0" spc="10" kern="0">
+                <a:solidFill>
+                  <a:srgbClr val="E4E1D8"/>
+                </a:solidFill>
+                <a:latin typeface="Be Vietnam Pro" pitchFamily="34" charset="0"/>
+                <a:ea typeface="Be Vietnam Pro" pitchFamily="34" charset="-122"/>
+                <a:cs typeface="Be Vietnam Pro" pitchFamily="34" charset="-120"/>
+              </a:rPr>
+              <a:t> sửa</a:t>
+            </a:r>
+            <a:r>
+              <a:rPr lang="en-US" sz="2400" dirty="0" spc="3" kern="0">
+                <a:solidFill>
+                  <a:srgbClr val="E4E1D8"/>
+                </a:solidFill>
+                <a:latin typeface="Be Vietnam Pro" pitchFamily="34" charset="0"/>
+                <a:ea typeface="Be Vietnam Pro" pitchFamily="34" charset="-122"/>
+                <a:cs typeface="Be Vietnam Pro" pitchFamily="34" charset="-120"/>
+              </a:rPr>
+              <a:t> dữ</a:t>
+            </a:r>
+            <a:r>
+              <a:rPr lang="en-US" sz="2400" dirty="0" spc="-1" kern="0">
+                <a:solidFill>
+                  <a:srgbClr val="E4E1D8"/>
+                </a:solidFill>
+                <a:latin typeface="Be Vietnam Pro" pitchFamily="34" charset="0"/>
+                <a:ea typeface="Be Vietnam Pro" pitchFamily="34" charset="-122"/>
+                <a:cs typeface="Be Vietnam Pro" pitchFamily="34" charset="-120"/>
+              </a:rPr>
+              <a:t> liệu</a:t>
             </a:r>
             <a:r>
               <a:rPr lang="en-US" sz="2400" dirty="0" spc="0" kern="0">
@@ -3552,161 +3585,7 @@
                 <a:ea typeface="Be Vietnam Pro" pitchFamily="34" charset="-122"/>
                 <a:cs typeface="Be Vietnam Pro" pitchFamily="34" charset="-120"/>
               </a:rPr>
-              <a:t> có cấu</a:t>
-            </a:r>
-            <a:r>
-              <a:rPr lang="en-US" sz="2400" dirty="0" spc="1" kern="0">
-                <a:solidFill>
-                  <a:srgbClr val="E4E1D8"/>
-                </a:solidFill>
-                <a:latin typeface="Be Vietnam Pro" pitchFamily="34" charset="0"/>
-                <a:ea typeface="Be Vietnam Pro" pitchFamily="34" charset="-122"/>
-                <a:cs typeface="Be Vietnam Pro" pitchFamily="34" charset="-120"/>
-              </a:rPr>
-              <a:t> trúc:</a:t>
-            </a:r>
-            <a:r>
-              <a:rPr lang="en-US" sz="2400" dirty="0" spc="0" kern="0">
-                <a:solidFill>
-                  <a:srgbClr val="E4E1D8"/>
-                </a:solidFill>
-                <a:latin typeface="Be Vietnam Pro" pitchFamily="34" charset="0"/>
-                <a:ea typeface="Be Vietnam Pro" pitchFamily="34" charset="-122"/>
-                <a:cs typeface="Be Vietnam Pro" pitchFamily="34" charset="-120"/>
-              </a:rPr>
-              <a:t> hỏi</a:t>
-            </a:r>
-            <a:r>
-              <a:rPr lang="en-US" sz="2400" dirty="0" spc="-15" kern="0">
-                <a:solidFill>
-                  <a:srgbClr val="E4E1D8"/>
-                </a:solidFill>
-                <a:latin typeface="Be Vietnam Pro" pitchFamily="34" charset="0"/>
-                <a:ea typeface="Be Vietnam Pro" pitchFamily="34" charset="-122"/>
-                <a:cs typeface="Be Vietnam Pro" pitchFamily="34" charset="-120"/>
-              </a:rPr>
-              <a:t> và</a:t>
-            </a:r>
-            <a:r>
-              <a:rPr lang="en-US" sz="2400" dirty="0" spc="-6" kern="0">
-                <a:solidFill>
-                  <a:srgbClr val="E4E1D8"/>
-                </a:solidFill>
-                <a:latin typeface="Be Vietnam Pro" pitchFamily="34" charset="0"/>
-                <a:ea typeface="Be Vietnam Pro" pitchFamily="34" charset="-122"/>
-                <a:cs typeface="Be Vietnam Pro" pitchFamily="34" charset="-120"/>
-              </a:rPr>
-              <a:t> thay</a:t>
-            </a:r>
-            <a:r>
-              <a:rPr lang="en-US" sz="2400" dirty="0" spc="12" kern="0">
-                <a:solidFill>
-                  <a:srgbClr val="E4E1D8"/>
-                </a:solidFill>
-                <a:latin typeface="Be Vietnam Pro" pitchFamily="34" charset="0"/>
-                <a:ea typeface="Be Vietnam Pro" pitchFamily="34" charset="-122"/>
-                <a:cs typeface="Be Vietnam Pro" pitchFamily="34" charset="-120"/>
-              </a:rPr>
-              <a:t> đổi</a:t>
-            </a:r>
-            <a:r>
-              <a:rPr lang="en-US" sz="2400" dirty="0" spc="4" kern="0">
-                <a:solidFill>
-                  <a:srgbClr val="E4E1D8"/>
-                </a:solidFill>
-                <a:latin typeface="Be Vietnam Pro" pitchFamily="34" charset="0"/>
-                <a:ea typeface="Be Vietnam Pro" pitchFamily="34" charset="-122"/>
-                <a:cs typeface="Be Vietnam Pro" pitchFamily="34" charset="-120"/>
-              </a:rPr>
-              <a:t> dữ</a:t>
-            </a:r>
-            <a:r>
-              <a:rPr lang="en-US" sz="2400" dirty="0" spc="-2" kern="0">
-                <a:solidFill>
-                  <a:srgbClr val="E4E1D8"/>
-                </a:solidFill>
-                <a:latin typeface="Be Vietnam Pro" pitchFamily="34" charset="0"/>
-                <a:ea typeface="Be Vietnam Pro" pitchFamily="34" charset="-122"/>
-                <a:cs typeface="Be Vietnam Pro" pitchFamily="34" charset="-120"/>
-              </a:rPr>
-              <a:t> liệu</a:t>
-            </a:r>
-            <a:r>
-              <a:rPr lang="en-US" sz="2400" dirty="0" spc="-13" kern="0">
-                <a:solidFill>
-                  <a:srgbClr val="E4E1D8"/>
-                </a:solidFill>
-                <a:latin typeface="Be Vietnam Pro" pitchFamily="34" charset="0"/>
-                <a:ea typeface="Be Vietnam Pro" pitchFamily="34" charset="-122"/>
-                <a:cs typeface="Be Vietnam Pro" pitchFamily="34" charset="-120"/>
-              </a:rPr>
-              <a:t> trong</a:t>
-            </a:r>
-            <a:r>
-              <a:rPr lang="en-US" sz="2400" dirty="0" spc="1" kern="0">
-                <a:solidFill>
-                  <a:srgbClr val="E4E1D8"/>
-                </a:solidFill>
-                <a:latin typeface="Be Vietnam Pro" pitchFamily="34" charset="0"/>
-                <a:ea typeface="Be Vietnam Pro" pitchFamily="34" charset="-122"/>
-                <a:cs typeface="Be Vietnam Pro" pitchFamily="34" charset="-120"/>
-              </a:rPr>
-              <a:t> cơ</a:t>
-            </a:r>
-            <a:r>
-              <a:rPr lang="en-US" sz="2400" dirty="0" spc="-9" kern="0">
-                <a:solidFill>
-                  <a:srgbClr val="E4E1D8"/>
-                </a:solidFill>
-                <a:latin typeface="Be Vietnam Pro" pitchFamily="34" charset="0"/>
-                <a:ea typeface="Be Vietnam Pro" pitchFamily="34" charset="-122"/>
-                <a:cs typeface="Be Vietnam Pro" pitchFamily="34" charset="-120"/>
-              </a:rPr>
-              <a:t> sở</a:t>
-            </a:r>
-            <a:r>
-              <a:rPr lang="en-US" sz="2400" dirty="0" spc="4" kern="0">
-                <a:solidFill>
-                  <a:srgbClr val="E4E1D8"/>
-                </a:solidFill>
-                <a:latin typeface="Be Vietnam Pro" pitchFamily="34" charset="0"/>
-                <a:ea typeface="Be Vietnam Pro" pitchFamily="34" charset="-122"/>
-                <a:cs typeface="Be Vietnam Pro" pitchFamily="34" charset="-120"/>
-              </a:rPr>
-              <a:t> dữ</a:t>
-            </a:r>
-            <a:r>
-              <a:rPr lang="en-US" sz="2400" dirty="0" spc="-2" kern="0">
-                <a:solidFill>
-                  <a:srgbClr val="E4E1D8"/>
-                </a:solidFill>
-                <a:latin typeface="Be Vietnam Pro" pitchFamily="34" charset="0"/>
-                <a:ea typeface="Be Vietnam Pro" pitchFamily="34" charset="-122"/>
-                <a:cs typeface="Be Vietnam Pro" pitchFamily="34" charset="-120"/>
-              </a:rPr>
-              <a:t> liệu</a:t>
-            </a:r>
-            <a:r>
-              <a:rPr lang="en-US" sz="2400" dirty="0" spc="1" kern="0">
-                <a:solidFill>
-                  <a:srgbClr val="E4E1D8"/>
-                </a:solidFill>
-                <a:latin typeface="Be Vietnam Pro" pitchFamily="34" charset="0"/>
-                <a:ea typeface="Be Vietnam Pro" pitchFamily="34" charset="-122"/>
-                <a:cs typeface="Be Vietnam Pro" pitchFamily="34" charset="-120"/>
-              </a:rPr>
-              <a:t> quan</a:t>
-            </a:r>
-            <a:r>
-              <a:rPr lang="en-US" sz="2400" dirty="0" spc="0" kern="0">
-                <a:solidFill>
-                  <a:srgbClr val="E4E1D8"/>
-                </a:solidFill>
-                <a:latin typeface="Be Vietnam Pro" pitchFamily="34" charset="0"/>
-                <a:ea typeface="Be Vietnam Pro" pitchFamily="34" charset="-122"/>
-                <a:cs typeface="Be Vietnam Pro" pitchFamily="34" charset="-120"/>
-              </a:rPr>
-              <a:t> hệ.</a:t>
+              <a:t> quan hệ.</a:t>
             </a:r>
             <a:endParaRPr lang="en-US" sz="2400" dirty="0"/>
           </a:p>
@@ -4252,6 +4131,50 @@
               <a:buNone/>
             </a:pPr>
             <a:r>
+              <a:rPr lang="en-US" sz="1950" dirty="0" spc="-6" kern="0">
+                <a:solidFill>
+                  <a:srgbClr val="9AA0B5"/>
+                </a:solidFill>
+                <a:latin typeface="Be Vietnam Pro" pitchFamily="34" charset="0"/>
+                <a:ea typeface="Be Vietnam Pro" pitchFamily="34" charset="-122"/>
+                <a:cs typeface="Be Vietnam Pro" pitchFamily="34" charset="-120"/>
+              </a:rPr>
+              <a:t>Đọc</a:t>
+            </a:r>
+            <a:r>
+              <a:rPr lang="en-US" sz="1950" dirty="0" spc="2" kern="0">
+                <a:solidFill>
+                  <a:srgbClr val="9AA0B5"/>
+                </a:solidFill>
+                <a:latin typeface="Be Vietnam Pro" pitchFamily="34" charset="0"/>
+                <a:ea typeface="Be Vietnam Pro" pitchFamily="34" charset="-122"/>
+                <a:cs typeface="Be Vietnam Pro" pitchFamily="34" charset="-120"/>
+              </a:rPr>
+              <a:t> nguồn</a:t>
+            </a:r>
+            <a:r>
+              <a:rPr lang="en-US" sz="1950" dirty="0" spc="0" kern="0">
+                <a:solidFill>
+                  <a:srgbClr val="9AA0B5"/>
+                </a:solidFill>
+                <a:latin typeface="Be Vietnam Pro" pitchFamily="34" charset="0"/>
+                <a:ea typeface="Be Vietnam Pro" pitchFamily="34" charset="-122"/>
+                <a:cs typeface="Be Vietnam Pro" pitchFamily="34" charset="-120"/>
+              </a:rPr>
+              <a:t> 2026-10-13;</a:t>
+            </a:r>
+            <a:r>
+              <a:rPr lang="en-US" sz="1950" dirty="0" spc="-8" kern="0">
+                <a:solidFill>
+                  <a:srgbClr val="9AA0B5"/>
+                </a:solidFill>
+                <a:latin typeface="Be Vietnam Pro" pitchFamily="34" charset="0"/>
+                <a:ea typeface="Be Vietnam Pro" pitchFamily="34" charset="-122"/>
+                <a:cs typeface="Be Vietnam Pro" pitchFamily="34" charset="-120"/>
+              </a:rPr>
+              <a:t> chạy</a:t>
+            </a:r>
+            <a:r>
               <a:rPr lang="en-US" sz="1950" dirty="0" spc="-1" kern="0">
                 <a:solidFill>
                   <a:srgbClr val="9AA0B5"/>
@@ -4260,10 +4183,10 @@
                 <a:ea typeface="Be Vietnam Pro" pitchFamily="34" charset="-122"/>
                 <a:cs typeface="Be Vietnam Pro" pitchFamily="34" charset="-120"/>
               </a:rPr>
-              <a:t>Đã</a:t>
-            </a:r>
-            <a:r>
-              <a:rPr lang="en-US" sz="1950" dirty="0" spc="6" kern="0">
+              <a:t> lại</a:t>
+            </a:r>
+            <a:r>
+              <a:rPr lang="en-US" sz="1950" dirty="0" spc="-15" kern="0">
                 <a:solidFill>
                   <a:srgbClr val="9AA0B5"/>
                 </a:solidFill>
@@ -4271,10 +4194,10 @@
                 <a:ea typeface="Be Vietnam Pro" pitchFamily="34" charset="-122"/>
                 <a:cs typeface="Be Vietnam Pro" pitchFamily="34" charset="-120"/>
               </a:rPr>
-              <a:t> đọc</a:t>
-            </a:r>
-            <a:r>
-              <a:rPr lang="en-US" sz="1950" dirty="0" spc="2" kern="0">
+              <a:t> trên</a:t>
+            </a:r>
+            <a:r>
+              <a:rPr lang="en-US" sz="1950" dirty="0" spc="0" kern="0">
                 <a:solidFill>
                   <a:srgbClr val="9AA0B5"/>
                 </a:solidFill>
@@ -4282,10 +4205,10 @@
                 <a:ea typeface="Be Vietnam Pro" pitchFamily="34" charset="-122"/>
                 <a:cs typeface="Be Vietnam Pro" pitchFamily="34" charset="-120"/>
               </a:rPr>
-              <a:t> nguồn</a:t>
-            </a:r>
-            <a:r>
-              <a:rPr lang="en-US" sz="1950" dirty="0" spc="-13" kern="0">
+              <a:t> SQLite</a:t>
+            </a:r>
+            <a:r>
+              <a:rPr lang="en-US" sz="1950" dirty="0" spc="-2" kern="0">
                 <a:solidFill>
                   <a:srgbClr val="9AA0B5"/>
                 </a:solidFill>
@@ -4293,150 +4216,7 @@
                 <a:ea typeface="Be Vietnam Pro" pitchFamily="34" charset="-122"/>
                 <a:cs typeface="Be Vietnam Pro" pitchFamily="34" charset="-120"/>
               </a:rPr>
-              <a:t> ngày</a:t>
-            </a:r>
-            <a:r>
-              <a:rPr lang="en-US" sz="1950" dirty="0" spc="-1" kern="0">
-                <a:solidFill>
-                  <a:srgbClr val="9AA0B5"/>
-                </a:solidFill>
-                <a:latin typeface="Be Vietnam Pro" pitchFamily="34" charset="0"/>
-                <a:ea typeface="Be Vietnam Pro" pitchFamily="34" charset="-122"/>
-                <a:cs typeface="Be Vietnam Pro" pitchFamily="34" charset="-120"/>
-              </a:rPr>
-              <a:t> 2026-10-13.</a:t>
-            </a:r>
-            <a:r>
-              <a:rPr lang="en-US" sz="1950" dirty="0" spc="-29" kern="0">
-                <a:solidFill>
-                  <a:srgbClr val="9AA0B5"/>
-                </a:solidFill>
-                <a:latin typeface="Be Vietnam Pro" pitchFamily="34" charset="0"/>
-                <a:ea typeface="Be Vietnam Pro" pitchFamily="34" charset="-122"/>
-                <a:cs typeface="Be Vietnam Pro" pitchFamily="34" charset="-120"/>
-              </a:rPr>
-              <a:t> Kết</a:t>
-            </a:r>
-            <a:r>
-              <a:rPr lang="en-US" sz="1950" dirty="0" spc="-1" kern="0">
-                <a:solidFill>
-                  <a:srgbClr val="9AA0B5"/>
-                </a:solidFill>
-                <a:latin typeface="Be Vietnam Pro" pitchFamily="34" charset="0"/>
-                <a:ea typeface="Be Vietnam Pro" pitchFamily="34" charset="-122"/>
-                <a:cs typeface="Be Vietnam Pro" pitchFamily="34" charset="-120"/>
-              </a:rPr>
-              <a:t> quả</a:t>
-            </a:r>
-            <a:r>
-              <a:rPr lang="en-US" sz="1950" dirty="0" spc="-8" kern="0">
-                <a:solidFill>
-                  <a:srgbClr val="9AA0B5"/>
-                </a:solidFill>
-                <a:latin typeface="Be Vietnam Pro" pitchFamily="34" charset="0"/>
-                <a:ea typeface="Be Vietnam Pro" pitchFamily="34" charset="-122"/>
-                <a:cs typeface="Be Vietnam Pro" pitchFamily="34" charset="-120"/>
-              </a:rPr>
-              <a:t> chạy</a:t>
-            </a:r>
-            <a:r>
-              <a:rPr lang="en-US" sz="1950" dirty="0" spc="-1" kern="0">
-                <a:solidFill>
-                  <a:srgbClr val="9AA0B5"/>
-                </a:solidFill>
-                <a:latin typeface="Be Vietnam Pro" pitchFamily="34" charset="0"/>
-                <a:ea typeface="Be Vietnam Pro" pitchFamily="34" charset="-122"/>
-                <a:cs typeface="Be Vietnam Pro" pitchFamily="34" charset="-120"/>
-              </a:rPr>
-              <a:t> lại</a:t>
-            </a:r>
-            <a:r>
-              <a:rPr lang="en-US" sz="1950" dirty="0" spc="-15" kern="0">
-                <a:solidFill>
-                  <a:srgbClr val="9AA0B5"/>
-                </a:solidFill>
-                <a:latin typeface="Be Vietnam Pro" pitchFamily="34" charset="0"/>
-                <a:ea typeface="Be Vietnam Pro" pitchFamily="34" charset="-122"/>
-                <a:cs typeface="Be Vietnam Pro" pitchFamily="34" charset="-120"/>
-              </a:rPr>
-              <a:t> trên</a:t>
-            </a:r>
-            <a:r>
-              <a:rPr lang="en-US" sz="1950" dirty="0" spc="0" kern="0">
-                <a:solidFill>
-                  <a:srgbClr val="9AA0B5"/>
-                </a:solidFill>
-                <a:latin typeface="Be Vietnam Pro" pitchFamily="34" charset="0"/>
-                <a:ea typeface="Be Vietnam Pro" pitchFamily="34" charset="-122"/>
-                <a:cs typeface="Be Vietnam Pro" pitchFamily="34" charset="-120"/>
-              </a:rPr>
-              <a:t> SQLite</a:t>
-            </a:r>
-            <a:r>
-              <a:rPr lang="en-US" sz="1950" dirty="0" spc="-2" kern="0">
-                <a:solidFill>
-                  <a:srgbClr val="9AA0B5"/>
-                </a:solidFill>
-                <a:latin typeface="Be Vietnam Pro" pitchFamily="34" charset="0"/>
-                <a:ea typeface="Be Vietnam Pro" pitchFamily="34" charset="-122"/>
-                <a:cs typeface="Be Vietnam Pro" pitchFamily="34" charset="-120"/>
-              </a:rPr>
               <a:t> 3.45.1.</a:t>
-            </a:r>
-            <a:r>
-              <a:rPr lang="en-US" sz="1950" dirty="0" spc="-1" kern="0">
-                <a:solidFill>
-                  <a:srgbClr val="9AA0B5"/>
-                </a:solidFill>
-                <a:latin typeface="Be Vietnam Pro" pitchFamily="34" charset="0"/>
-                <a:ea typeface="Be Vietnam Pro" pitchFamily="34" charset="-122"/>
-                <a:cs typeface="Be Vietnam Pro" pitchFamily="34" charset="-120"/>
-              </a:rPr>
-              <a:t> Hình</a:t>
-            </a:r>
-            <a:r>
-              <a:rPr lang="en-US" sz="1950" dirty="0" spc="-4" kern="0">
-                <a:solidFill>
-                  <a:srgbClr val="9AA0B5"/>
-                </a:solidFill>
-                <a:latin typeface="Be Vietnam Pro" pitchFamily="34" charset="0"/>
-                <a:ea typeface="Be Vietnam Pro" pitchFamily="34" charset="-122"/>
-                <a:cs typeface="Be Vietnam Pro" pitchFamily="34" charset="-120"/>
-              </a:rPr>
-              <a:t> thiết</a:t>
-            </a:r>
-            <a:r>
-              <a:rPr lang="en-US" sz="1950" dirty="0" spc="-31" kern="0">
-                <a:solidFill>
-                  <a:srgbClr val="9AA0B5"/>
-                </a:solidFill>
-                <a:latin typeface="Be Vietnam Pro" pitchFamily="34" charset="0"/>
-                <a:ea typeface="Be Vietnam Pro" pitchFamily="34" charset="-122"/>
-                <a:cs typeface="Be Vietnam Pro" pitchFamily="34" charset="-120"/>
-              </a:rPr>
-              <a:t> kế</a:t>
-            </a:r>
-            <a:r>
-              <a:rPr lang="en-US" sz="1950" dirty="0" spc="6" kern="0">
-                <a:solidFill>
-                  <a:srgbClr val="9AA0B5"/>
-                </a:solidFill>
-                <a:latin typeface="Be Vietnam Pro" pitchFamily="34" charset="0"/>
-                <a:ea typeface="Be Vietnam Pro" pitchFamily="34" charset="-122"/>
-                <a:cs typeface="Be Vietnam Pro" pitchFamily="34" charset="-120"/>
-              </a:rPr>
-              <a:t> độc</a:t>
-            </a:r>
-            <a:r>
-              <a:rPr lang="en-US" sz="1950" dirty="0" spc="-3" kern="0">
-                <a:solidFill>
-                  <a:srgbClr val="9AA0B5"/>
-                </a:solidFill>
-                <a:latin typeface="Be Vietnam Pro" pitchFamily="34" charset="0"/>
-                <a:ea typeface="Be Vietnam Pro" pitchFamily="34" charset="-122"/>
-                <a:cs typeface="Be Vietnam Pro" pitchFamily="34" charset="-120"/>
-              </a:rPr>
-              <a:t> lập.</a:t>
             </a:r>
             <a:endParaRPr lang="en-US" sz="1950" dirty="0"/>
           </a:p>
@@ -16002,10 +15782,10 @@
                 <a:ea typeface="Be Vietnam Pro" pitchFamily="34" charset="-122"/>
                 <a:cs typeface="Be Vietnam Pro" pitchFamily="34" charset="-120"/>
               </a:rPr>
-              <a:t> NULL</a:t>
-            </a:r>
-            <a:r>
-              <a:rPr lang="en-US" sz="2550" dirty="0" spc="-1" kern="0">
+              <a:t> NULL:</a:t>
+            </a:r>
+            <a:r>
+              <a:rPr lang="en-US" sz="2550" dirty="0" spc="0" kern="0">
                 <a:solidFill>
                   <a:srgbClr val="14161C"/>
                 </a:solidFill>
@@ -16013,40 +15793,7 @@
                 <a:ea typeface="Be Vietnam Pro" pitchFamily="34" charset="-122"/>
                 <a:cs typeface="Be Vietnam Pro" pitchFamily="34" charset="-120"/>
               </a:rPr>
-              <a:t> cho</a:t>
-            </a:r>
-            <a:r>
-              <a:rPr lang="en-US" sz="2550" dirty="0" spc="0" kern="0">
-                <a:solidFill>
-                  <a:srgbClr val="14161C"/>
-                </a:solidFill>
-                <a:latin typeface="Be Vietnam Pro" pitchFamily="34" charset="0"/>
-                <a:ea typeface="Be Vietnam Pro" pitchFamily="34" charset="-122"/>
-                <a:cs typeface="Be Vietnam Pro" pitchFamily="34" charset="-120"/>
-              </a:rPr>
-              <a:t> Binh</a:t>
-            </a:r>
-            <a:r>
-              <a:rPr lang="en-US" sz="2550" dirty="0" spc="-18" kern="0">
-                <a:solidFill>
-                  <a:srgbClr val="14161C"/>
-                </a:solidFill>
-                <a:latin typeface="Be Vietnam Pro" pitchFamily="34" charset="0"/>
-                <a:ea typeface="Be Vietnam Pro" pitchFamily="34" charset="-122"/>
-                <a:cs typeface="Be Vietnam Pro" pitchFamily="34" charset="-120"/>
-              </a:rPr>
-              <a:t> và</a:t>
-            </a:r>
-            <a:r>
-              <a:rPr lang="en-US" sz="2550" dirty="0" spc="1" kern="0">
-                <a:solidFill>
-                  <a:srgbClr val="14161C"/>
-                </a:solidFill>
-                <a:latin typeface="Be Vietnam Pro" pitchFamily="34" charset="0"/>
-                <a:ea typeface="Be Vietnam Pro" pitchFamily="34" charset="-122"/>
-                <a:cs typeface="Be Vietnam Pro" pitchFamily="34" charset="-120"/>
-              </a:rPr>
-              <a:t> Chi.</a:t>
+              <a:t> Binh, Chi.</a:t>
             </a:r>
             <a:endParaRPr lang="en-US" sz="2550" dirty="0"/>
           </a:p>

</xml_diff>